<commit_message>
Audit final deliverables, preserve PR files and package submission
</commit_message>
<xml_diff>
--- a/output/presentation/PRESENTATION_FINAL.pptx
+++ b/output/presentation/PRESENTATION_FINAL.pptx
@@ -12545,7 +12545,7 @@
                 <a:ea typeface="Arial"/>
                 <a:cs typeface="Arial"/>
               </a:rPr>
-              <a:t>PRODUCT MANAGER</a:t>
+              <a:t>PRODUCT MANAGER · активное</a:t>
             </a:r>
           </a:p>
         </p:txBody>
@@ -12836,7 +12836,7 @@
                 <a:ea typeface="Arial"/>
                 <a:cs typeface="Arial"/>
               </a:rPr>
-              <a:t>ML ENGINEER</a:t>
+              <a:t>ML ENGINEER · активное</a:t>
             </a:r>
           </a:p>
         </p:txBody>
@@ -13127,7 +13127,7 @@
                 <a:ea typeface="Arial"/>
                 <a:cs typeface="Arial"/>
               </a:rPr>
-              <a:t>ML ENGINEER</a:t>
+              <a:t>ML ENGINEER · активное</a:t>
             </a:r>
           </a:p>
         </p:txBody>

</xml_diff>